<commit_message>
Update Project 14 poster PDF and PPTX
Replace poster files for 'Predictive Modeling of Root-Zone Variables Using Greenhouse Data - Project 14' with updated PDF and PowerPoint binaries. These updates contain revised poster content and/or layout in both the PDF and PPTX versions.
</commit_message>
<xml_diff>
--- a/poster/Predictive Modeling of Root-Zone Variables Using Greenhouse Data - Project 14.pptx
+++ b/poster/Predictive Modeling of Root-Zone Variables Using Greenhouse Data - Project 14.pptx
@@ -12201,11 +12201,11 @@
               </a:spcAft>
             </a:pPr>
             <a:r>
-              <a:rPr sz="3600" b="1" i="0">
+              <a:rPr sz="3600" b="1" i="0" dirty="0">
                 <a:solidFill>
                   <a:srgbClr val="FFFFFF"/>
                 </a:solidFill>
-                <a:latin typeface="Calibri"/>
+                <a:latin typeface="+mj-lt"/>
               </a:rPr>
               <a:t>01</a:t>
             </a:r>
@@ -12250,7 +12250,7 @@
                 <a:solidFill>
                   <a:srgbClr val="3D4A1F"/>
                 </a:solidFill>
-                <a:latin typeface="Calibri"/>
+                <a:latin typeface="+mj-lt"/>
               </a:rPr>
               <a:t>Motivation</a:t>
             </a:r>
@@ -12265,7 +12265,7 @@
         </p:nvSpPr>
         <p:spPr>
           <a:xfrm>
-            <a:off x="936000" y="4687200"/>
+            <a:off x="936000" y="4661800"/>
             <a:ext cx="11087999" cy="16200"/>
           </a:xfrm>
           <a:prstGeom prst="rect">
@@ -12310,8 +12310,8 @@
         </p:nvSpPr>
         <p:spPr>
           <a:xfrm>
-            <a:off x="954000" y="4729800"/>
-            <a:ext cx="11376000" cy="3380596"/>
+            <a:off x="954000" y="4679000"/>
+            <a:ext cx="11376000" cy="3316476"/>
           </a:xfrm>
           <a:prstGeom prst="rect">
             <a:avLst/>
@@ -12324,13 +12324,10 @@
           </a:bodyPr>
           <a:lstStyle/>
           <a:p>
-            <a:pPr algn="l">
+            <a:pPr>
               <a:lnSpc>
                 <a:spcPct val="106000"/>
               </a:lnSpc>
-              <a:spcBef>
-                <a:spcPts val="0"/>
-              </a:spcBef>
               <a:spcAft>
                 <a:spcPts val="500"/>
               </a:spcAft>
@@ -12345,41 +12342,50 @@
               <a:t>▪  </a:t>
             </a:r>
             <a:r>
-              <a:rPr sz="2400" b="0" dirty="0">
+              <a:rPr lang="en-US" sz="2400" dirty="0">
                 <a:solidFill>
-                  <a:srgbClr val="2E3517"/>
+                  <a:schemeClr val="tx2">
+                    <a:lumMod val="75000"/>
+                  </a:schemeClr>
+                </a:solidFill>
+              </a:rPr>
+              <a:t>Root-zone pH governs nutrient availability, while EC reflects salinity and fertilizer load - both directly affect crop health, growth and yield.</a:t>
+            </a:r>
+            <a:br>
+              <a:rPr lang="en-US" sz="2400" dirty="0"/>
+            </a:br>
+            <a:r>
+              <a:rPr sz="2400" b="1" dirty="0">
+                <a:solidFill>
+                  <a:srgbClr val="5E6E2E"/>
                 </a:solidFill>
                 <a:latin typeface="Calibri"/>
               </a:rPr>
-              <a:t>Root-zone pH governs nutrient availability and EC reflects salinity and fertilizer load </a:t>
+              <a:t>▪  </a:t>
             </a:r>
             <a:r>
-              <a:rPr lang="he-IL" sz="2400" b="0" dirty="0">
+              <a:rPr lang="en-US" sz="2400" dirty="0">
                 <a:solidFill>
-                  <a:srgbClr val="2E3517"/>
+                  <a:schemeClr val="tx2">
+                    <a:lumMod val="75000"/>
+                  </a:schemeClr>
                 </a:solidFill>
-                <a:latin typeface="Calibri"/>
               </a:rPr>
-              <a:t>- </a:t>
+              <a:t>In soilless greenhouse systems, the root zone has low buffering capacity, so irrigation or fertigation errors can quickly affect plant conditions.</a:t>
             </a:r>
-            <a:r>
-              <a:rPr sz="2400" b="0" dirty="0">
-                <a:solidFill>
-                  <a:srgbClr val="2E3517"/>
-                </a:solidFill>
-                <a:latin typeface="Calibri"/>
-              </a:rPr>
-              <a:t>both directly drive crop health and yield.</a:t>
-            </a:r>
+            <a:endParaRPr lang="he-IL" sz="2400" dirty="0">
+              <a:solidFill>
+                <a:schemeClr val="tx2">
+                  <a:lumMod val="75000"/>
+                </a:schemeClr>
+              </a:solidFill>
+            </a:endParaRPr>
           </a:p>
           <a:p>
-            <a:pPr algn="l">
+            <a:pPr>
               <a:lnSpc>
                 <a:spcPct val="106000"/>
               </a:lnSpc>
-              <a:spcBef>
-                <a:spcPts val="0"/>
-              </a:spcBef>
               <a:spcAft>
                 <a:spcPts val="500"/>
               </a:spcAft>
@@ -12394,23 +12400,28 @@
               <a:t>▪  </a:t>
             </a:r>
             <a:r>
-              <a:rPr sz="2400" b="0" dirty="0">
+              <a:rPr lang="en-US" sz="2400" dirty="0">
                 <a:solidFill>
-                  <a:srgbClr val="2E3517"/>
+                  <a:schemeClr val="tx2">
+                    <a:lumMod val="75000"/>
+                  </a:schemeClr>
                 </a:solidFill>
-                <a:latin typeface="Calibri"/>
               </a:rPr>
-              <a:t>Manual laboratory pH/EC samples are accurate but sparse, slow and reactive, leaving long blind gaps between measurements.</a:t>
+              <a:t>Manual laboratory pH/EC samples are accurate, but sparse, slow and reactive, leaving long blind gaps between measurements.</a:t>
             </a:r>
+            <a:endParaRPr lang="he-IL" sz="2400" dirty="0">
+              <a:solidFill>
+                <a:schemeClr val="tx2">
+                  <a:lumMod val="75000"/>
+                </a:schemeClr>
+              </a:solidFill>
+            </a:endParaRPr>
           </a:p>
           <a:p>
-            <a:pPr algn="l">
+            <a:pPr>
               <a:lnSpc>
                 <a:spcPct val="106000"/>
               </a:lnSpc>
-              <a:spcBef>
-                <a:spcPts val="0"/>
-              </a:spcBef>
               <a:spcAft>
                 <a:spcPts val="500"/>
               </a:spcAft>
@@ -12425,45 +12436,23 @@
               <a:t>▪  </a:t>
             </a:r>
             <a:r>
-              <a:rPr sz="2400" b="0" dirty="0">
+              <a:rPr lang="en-US" sz="2400" dirty="0">
                 <a:solidFill>
-                  <a:srgbClr val="2E3517"/>
+                  <a:schemeClr val="tx2">
+                    <a:lumMod val="75000"/>
+                  </a:schemeClr>
                 </a:solidFill>
-                <a:latin typeface="Calibri"/>
               </a:rPr>
-              <a:t>Continuous probes drift, need frequent calibration and sample only a single point of the root zone.</a:t>
+              <a:t>Continuous probes can provide dense data, but they may drift, require frequent calibration and represent only a single point in the root zone.</a:t>
             </a:r>
-          </a:p>
-          <a:p>
-            <a:pPr algn="l">
-              <a:lnSpc>
-                <a:spcPct val="106000"/>
-              </a:lnSpc>
-              <a:spcBef>
-                <a:spcPts val="0"/>
-              </a:spcBef>
-              <a:spcAft>
-                <a:spcPts val="500"/>
-              </a:spcAft>
-            </a:pPr>
-            <a:r>
-              <a:rPr sz="2400" b="1" dirty="0">
-                <a:solidFill>
-                  <a:srgbClr val="5E6E2E"/>
-                </a:solidFill>
-                <a:latin typeface="Calibri"/>
-              </a:rPr>
-              <a:t>▪  </a:t>
-            </a:r>
-            <a:r>
-              <a:rPr sz="2400" b="0" dirty="0">
-                <a:solidFill>
-                  <a:srgbClr val="2E3517"/>
-                </a:solidFill>
-                <a:latin typeface="Calibri"/>
-              </a:rPr>
-              <a:t>A machine-learning soft sensor fills these gaps, enabling proactive irrigation and fertigation decisions.</a:t>
-            </a:r>
+            <a:endParaRPr sz="2400" b="0" dirty="0">
+              <a:solidFill>
+                <a:schemeClr val="tx2">
+                  <a:lumMod val="75000"/>
+                </a:schemeClr>
+              </a:solidFill>
+              <a:latin typeface="Calibri"/>
+            </a:endParaRPr>
           </a:p>
         </p:txBody>
       </p:sp>
@@ -12512,7 +12501,7 @@
           <a:lstStyle/>
           <a:p>
             <a:pPr algn="ctr"/>
-            <a:endParaRPr/>
+            <a:endParaRPr dirty="0"/>
           </a:p>
         </p:txBody>
       </p:sp>
@@ -12570,11 +12559,11 @@
               </a:spcAft>
             </a:pPr>
             <a:r>
-              <a:rPr sz="3600" b="1" i="0">
+              <a:rPr sz="3600" b="1" i="0" dirty="0">
                 <a:solidFill>
                   <a:srgbClr val="FFFFFF"/>
                 </a:solidFill>
-                <a:latin typeface="Calibri"/>
+                <a:latin typeface="+mj-lt"/>
               </a:rPr>
               <a:t>02</a:t>
             </a:r>
@@ -12615,11 +12604,11 @@
               </a:spcAft>
             </a:pPr>
             <a:r>
-              <a:rPr sz="3600" b="1" i="0">
+              <a:rPr sz="3600" b="1" i="0" dirty="0">
                 <a:solidFill>
                   <a:srgbClr val="3D4A1F"/>
                 </a:solidFill>
-                <a:latin typeface="Calibri"/>
+                <a:latin typeface="+mj-lt"/>
               </a:rPr>
               <a:t>Project Goal</a:t>
             </a:r>
@@ -12634,7 +12623,7 @@
         </p:nvSpPr>
         <p:spPr>
           <a:xfrm>
-            <a:off x="936000" y="9221400"/>
+            <a:off x="936000" y="9196000"/>
             <a:ext cx="11087999" cy="16200"/>
           </a:xfrm>
           <a:prstGeom prst="rect">
@@ -12679,8 +12668,8 @@
         </p:nvSpPr>
         <p:spPr>
           <a:xfrm>
-            <a:off x="954000" y="9343888"/>
-            <a:ext cx="11160000" cy="1699110"/>
+            <a:off x="969824" y="9173842"/>
+            <a:ext cx="11160000" cy="2873663"/>
           </a:xfrm>
           <a:prstGeom prst="rect">
             <a:avLst/>
@@ -12693,84 +12682,125 @@
           </a:bodyPr>
           <a:lstStyle/>
           <a:p>
-            <a:pPr algn="l">
+            <a:pPr>
               <a:lnSpc>
                 <a:spcPct val="106000"/>
               </a:lnSpc>
-              <a:spcBef>
-                <a:spcPts val="0"/>
-              </a:spcBef>
               <a:spcAft>
                 <a:spcPts val="600"/>
               </a:spcAft>
             </a:pPr>
             <a:r>
-              <a:rPr sz="2400" b="1" dirty="0">
+              <a:rPr lang="he-IL" sz="2400" b="1" dirty="0">
                 <a:solidFill>
                   <a:srgbClr val="5E6E2E"/>
                 </a:solidFill>
-                <a:latin typeface="Calibri"/>
               </a:rPr>
-              <a:t>▪  </a:t>
+              <a:t>▪</a:t>
             </a:r>
             <a:r>
-              <a:rPr sz="2400" b="0" dirty="0">
+              <a:rPr sz="2400" b="1" dirty="0">
                 <a:solidFill>
-                  <a:srgbClr val="2E3517"/>
+                  <a:schemeClr val="tx2">
+                    <a:lumMod val="75000"/>
+                  </a:schemeClr>
                 </a:solidFill>
                 <a:latin typeface="Calibri"/>
               </a:rPr>
-              <a:t>Build a machine-learning soft sensor that continuously estimates root-zone pH and EC between sparse manual lab samples.</a:t>
+              <a:t>  </a:t>
             </a:r>
+            <a:r>
+              <a:rPr lang="en-US" sz="2400" dirty="0">
+                <a:solidFill>
+                  <a:schemeClr val="tx2">
+                    <a:lumMod val="75000"/>
+                  </a:schemeClr>
+                </a:solidFill>
+              </a:rPr>
+              <a:t>Build a machine-learning soft sensor that estimates future root-zone pH and EC between sparse manual laboratory samples.</a:t>
+            </a:r>
+            <a:br>
+              <a:rPr lang="en-US" sz="2400" dirty="0">
+                <a:solidFill>
+                  <a:schemeClr val="tx2">
+                    <a:lumMod val="75000"/>
+                  </a:schemeClr>
+                </a:solidFill>
+              </a:rPr>
+            </a:br>
+            <a:r>
+              <a:rPr lang="he-IL" sz="2400" b="1" dirty="0">
+                <a:solidFill>
+                  <a:srgbClr val="5E6E2E"/>
+                </a:solidFill>
+              </a:rPr>
+              <a:t>▪</a:t>
+            </a:r>
+            <a:r>
+              <a:rPr sz="2400" b="1" dirty="0">
+                <a:solidFill>
+                  <a:schemeClr val="tx2">
+                    <a:lumMod val="75000"/>
+                  </a:schemeClr>
+                </a:solidFill>
+                <a:latin typeface="Calibri"/>
+              </a:rPr>
+              <a:t>  </a:t>
+            </a:r>
+            <a:r>
+              <a:rPr lang="en-US" sz="2400" dirty="0">
+                <a:solidFill>
+                  <a:schemeClr val="tx2">
+                    <a:lumMod val="75000"/>
+                  </a:schemeClr>
+                </a:solidFill>
+              </a:rPr>
+              <a:t>Predict the change from a known baseline measurement at t₀ to a future target time t₁ using climate, irrigation, fertigation, crop-state and previous pH/EC information.</a:t>
+            </a:r>
+            <a:endParaRPr lang="he-IL" sz="2400" dirty="0">
+              <a:solidFill>
+                <a:schemeClr val="tx2">
+                  <a:lumMod val="75000"/>
+                </a:schemeClr>
+              </a:solidFill>
+            </a:endParaRPr>
           </a:p>
           <a:p>
-            <a:pPr algn="l">
+            <a:pPr>
               <a:lnSpc>
                 <a:spcPct val="106000"/>
               </a:lnSpc>
-              <a:spcBef>
-                <a:spcPts val="0"/>
-              </a:spcBef>
               <a:spcAft>
                 <a:spcPts val="600"/>
               </a:spcAft>
             </a:pPr>
             <a:r>
-              <a:rPr sz="2400" b="1" dirty="0">
+              <a:rPr lang="he-IL" sz="2400" b="1" dirty="0">
                 <a:solidFill>
                   <a:srgbClr val="5E6E2E"/>
                 </a:solidFill>
-                <a:latin typeface="Calibri"/>
               </a:rPr>
-              <a:t>▪  </a:t>
+              <a:t>▪</a:t>
             </a:r>
             <a:r>
-              <a:rPr sz="2400" b="0" dirty="0">
+              <a:rPr lang="en-US" sz="2400" dirty="0">
                 <a:solidFill>
-                  <a:srgbClr val="2E3517"/>
+                  <a:schemeClr val="tx2">
+                    <a:lumMod val="75000"/>
+                  </a:schemeClr>
                 </a:solidFill>
-                <a:latin typeface="Calibri"/>
               </a:rPr>
-              <a:t>Deliver reliable interpolated values so growers act on pH or salinity drift early </a:t>
+              <a:t> Provide reliable decision-support values that help growers detect pH or salinity drift earlier and maintain the root zone within an optimal operating range.</a:t>
             </a:r>
-            <a:r>
-              <a:rPr lang="he-IL" sz="2400" b="0" dirty="0">
-                <a:solidFill>
-                  <a:srgbClr val="2E3517"/>
-                </a:solidFill>
-                <a:latin typeface="Calibri"/>
-              </a:rPr>
-              <a:t>-</a:t>
-            </a:r>
-            <a:r>
-              <a:rPr sz="2400" b="0" dirty="0">
-                <a:solidFill>
-                  <a:srgbClr val="2E3517"/>
-                </a:solidFill>
-                <a:latin typeface="Calibri"/>
-              </a:rPr>
-              <a:t> supporting timely irrigation and fertigation and keeping the root zone in its optimal band.</a:t>
-            </a:r>
+            <a:br>
+              <a:rPr lang="en-US" sz="2400" dirty="0"/>
+            </a:br>
+            <a:endParaRPr sz="2400" b="0" dirty="0">
+              <a:solidFill>
+                <a:srgbClr val="2E3517"/>
+              </a:solidFill>
+              <a:latin typeface="Calibri"/>
+            </a:endParaRPr>
           </a:p>
         </p:txBody>
       </p:sp>
@@ -12877,11 +12907,11 @@
               </a:spcAft>
             </a:pPr>
             <a:r>
-              <a:rPr sz="3600" b="1" i="0">
+              <a:rPr sz="3600" b="1" i="0" dirty="0">
                 <a:solidFill>
                   <a:srgbClr val="FFFFFF"/>
                 </a:solidFill>
-                <a:latin typeface="Calibri"/>
+                <a:latin typeface="+mj-lt"/>
               </a:rPr>
               <a:t>03</a:t>
             </a:r>
@@ -12922,11 +12952,11 @@
               </a:spcAft>
             </a:pPr>
             <a:r>
-              <a:rPr sz="3600" b="1" i="0">
+              <a:rPr sz="3600" b="1" i="0" dirty="0">
                 <a:solidFill>
                   <a:srgbClr val="3D4A1F"/>
                 </a:solidFill>
-                <a:latin typeface="Calibri"/>
+                <a:latin typeface="+mj-lt"/>
               </a:rPr>
               <a:t>Data</a:t>
             </a:r>
@@ -13206,14 +13236,20 @@
               </a:spcAft>
             </a:pPr>
             <a:r>
-              <a:rPr sz="4400" b="1" i="0" dirty="0">
+              <a:rPr lang="he-IL" sz="4400" b="1" i="0" dirty="0">
                 <a:solidFill>
                   <a:srgbClr val="3D4A1F"/>
                 </a:solidFill>
-                <a:latin typeface="Calibri"/>
+                <a:latin typeface="+mj-lt"/>
               </a:rPr>
-              <a:t>20</a:t>
+              <a:t>20+</a:t>
             </a:r>
+            <a:endParaRPr sz="4400" b="1" i="0" dirty="0">
+              <a:solidFill>
+                <a:srgbClr val="3D4A1F"/>
+              </a:solidFill>
+              <a:latin typeface="+mj-lt"/>
+            </a:endParaRPr>
           </a:p>
           <a:p>
             <a:pPr algn="ctr">
@@ -13247,8 +13283,8 @@
         </p:nvSpPr>
         <p:spPr>
           <a:xfrm>
-            <a:off x="954000" y="14381999"/>
-            <a:ext cx="11052000" cy="2664000"/>
+            <a:off x="954000" y="14280399"/>
+            <a:ext cx="11160000" cy="2796719"/>
           </a:xfrm>
           <a:prstGeom prst="rect">
             <a:avLst/>
@@ -13261,262 +13297,175 @@
           </a:bodyPr>
           <a:lstStyle/>
           <a:p>
-            <a:pPr algn="l">
+            <a:pPr>
               <a:lnSpc>
                 <a:spcPct val="106000"/>
               </a:lnSpc>
-              <a:spcBef>
-                <a:spcPts val="0"/>
-              </a:spcBef>
               <a:spcAft>
                 <a:spcPts val="400"/>
               </a:spcAft>
             </a:pPr>
             <a:r>
-              <a:rPr sz="2400" b="1" dirty="0">
+              <a:rPr lang="he-IL" sz="2400" b="1" dirty="0">
                 <a:solidFill>
                   <a:srgbClr val="5E6E2E"/>
                 </a:solidFill>
-                <a:latin typeface="Calibri"/>
               </a:rPr>
-              <a:t>▪  </a:t>
+              <a:t>▪</a:t>
             </a:r>
             <a:r>
-              <a:rPr sz="2400" b="0" dirty="0">
+              <a:rPr lang="en-US" sz="2400" dirty="0">
                 <a:solidFill>
-                  <a:srgbClr val="2E3517"/>
+                  <a:schemeClr val="tx2">
+                    <a:lumMod val="75000"/>
+                  </a:schemeClr>
                 </a:solidFill>
-                <a:latin typeface="Calibri"/>
               </a:rPr>
-              <a:t>Unified 10-minute master dataset · May 29 – Sep 21 2025.</a:t>
+              <a:t> Unified 10-minute master dataset · May 29 – Sep 21, 2025.</a:t>
             </a:r>
-          </a:p>
-          <a:p>
-            <a:pPr algn="l">
-              <a:lnSpc>
-                <a:spcPct val="106000"/>
-              </a:lnSpc>
-              <a:spcBef>
-                <a:spcPts val="0"/>
-              </a:spcBef>
-              <a:spcAft>
-                <a:spcPts val="400"/>
-              </a:spcAft>
-            </a:pPr>
+            <a:br>
+              <a:rPr lang="en-US" sz="2400" dirty="0">
+                <a:solidFill>
+                  <a:schemeClr val="tx2">
+                    <a:lumMod val="75000"/>
+                  </a:schemeClr>
+                </a:solidFill>
+              </a:rPr>
+            </a:br>
             <a:r>
-              <a:rPr sz="2400" b="1" dirty="0">
+              <a:rPr lang="he-IL" sz="2400" b="1" dirty="0">
                 <a:solidFill>
                   <a:srgbClr val="5E6E2E"/>
                 </a:solidFill>
-                <a:latin typeface="Calibri"/>
               </a:rPr>
-              <a:t>▪  </a:t>
+              <a:t>▪</a:t>
             </a:r>
             <a:r>
-              <a:rPr sz="2400" b="0" dirty="0">
+              <a:rPr lang="en-US" sz="2400" dirty="0">
                 <a:solidFill>
-                  <a:srgbClr val="2E3517"/>
+                  <a:schemeClr val="tx2">
+                    <a:lumMod val="75000"/>
+                  </a:schemeClr>
                 </a:solidFill>
-                <a:latin typeface="Calibri"/>
               </a:rPr>
-              <a:t>External weather &amp; solar radiation (open-field station).</a:t>
+              <a:t> External weather &amp; solar radiation — open-field weather and radiation measurements.</a:t>
             </a:r>
-          </a:p>
-          <a:p>
-            <a:pPr algn="l">
-              <a:lnSpc>
-                <a:spcPct val="106000"/>
-              </a:lnSpc>
-              <a:spcBef>
-                <a:spcPts val="0"/>
-              </a:spcBef>
-              <a:spcAft>
-                <a:spcPts val="400"/>
-              </a:spcAft>
-            </a:pPr>
+            <a:br>
+              <a:rPr lang="en-US" sz="2400" dirty="0">
+                <a:solidFill>
+                  <a:schemeClr val="tx2">
+                    <a:lumMod val="75000"/>
+                  </a:schemeClr>
+                </a:solidFill>
+              </a:rPr>
+            </a:br>
             <a:r>
-              <a:rPr sz="2400" b="1" dirty="0">
+              <a:rPr lang="he-IL" sz="2400" b="1" dirty="0">
                 <a:solidFill>
                   <a:srgbClr val="5E6E2E"/>
                 </a:solidFill>
-                <a:latin typeface="Calibri"/>
               </a:rPr>
-              <a:t>▪  </a:t>
+              <a:t>▪</a:t>
             </a:r>
             <a:r>
-              <a:rPr sz="2400" b="0" dirty="0">
+              <a:rPr lang="en-US" sz="2400" dirty="0">
                 <a:solidFill>
-                  <a:srgbClr val="2E3517"/>
+                  <a:schemeClr val="tx2">
+                    <a:lumMod val="75000"/>
+                  </a:schemeClr>
                 </a:solidFill>
-                <a:latin typeface="Calibri"/>
               </a:rPr>
-              <a:t>Greenhouse climate </a:t>
+              <a:t> Greenhouse micro-climate — internal air temperature, relative humidity, radiation, ET₀ and soil temperature.</a:t>
             </a:r>
+            <a:br>
+              <a:rPr lang="en-US" sz="2400" dirty="0">
+                <a:solidFill>
+                  <a:schemeClr val="tx2">
+                    <a:lumMod val="75000"/>
+                  </a:schemeClr>
+                </a:solidFill>
+              </a:rPr>
+            </a:br>
             <a:r>
-              <a:rPr lang="he-IL" sz="2400" b="0" dirty="0">
-                <a:solidFill>
-                  <a:srgbClr val="2E3517"/>
-                </a:solidFill>
-                <a:latin typeface="Calibri"/>
-              </a:rPr>
-              <a:t>-</a:t>
-            </a:r>
-            <a:r>
-              <a:rPr sz="2400" b="0" dirty="0">
-                <a:solidFill>
-                  <a:srgbClr val="2E3517"/>
-                </a:solidFill>
-                <a:latin typeface="Calibri"/>
-              </a:rPr>
-              <a:t> air temperature, RH, radiation, ET₀.</a:t>
-            </a:r>
-          </a:p>
-          <a:p>
-            <a:pPr algn="l">
-              <a:lnSpc>
-                <a:spcPct val="106000"/>
-              </a:lnSpc>
-              <a:spcBef>
-                <a:spcPts val="0"/>
-              </a:spcBef>
-              <a:spcAft>
-                <a:spcPts val="400"/>
-              </a:spcAft>
-            </a:pPr>
-            <a:r>
-              <a:rPr sz="2400" b="1" dirty="0">
+              <a:rPr lang="he-IL" sz="2400" b="1" dirty="0">
                 <a:solidFill>
                   <a:srgbClr val="5E6E2E"/>
                 </a:solidFill>
-                <a:latin typeface="Calibri"/>
               </a:rPr>
-              <a:t>▪  </a:t>
+              <a:t>▪</a:t>
             </a:r>
             <a:r>
-              <a:rPr sz="2400" b="0" dirty="0">
+              <a:rPr lang="en-US" sz="2400" dirty="0">
                 <a:solidFill>
-                  <a:srgbClr val="2E3517"/>
+                  <a:schemeClr val="tx2">
+                    <a:lumMod val="75000"/>
+                  </a:schemeClr>
                 </a:solidFill>
-                <a:latin typeface="Calibri"/>
               </a:rPr>
-              <a:t>Irrigation &amp; fertigation </a:t>
+              <a:t> Irrigation &amp; fertigation — water volume, fertilizer, EC, acid dosing and event timing.</a:t>
             </a:r>
+            <a:br>
+              <a:rPr lang="en-US" sz="2400" dirty="0">
+                <a:solidFill>
+                  <a:schemeClr val="tx2">
+                    <a:lumMod val="75000"/>
+                  </a:schemeClr>
+                </a:solidFill>
+              </a:rPr>
+            </a:br>
             <a:r>
-              <a:rPr lang="he-IL" sz="2400" b="0" dirty="0">
-                <a:solidFill>
-                  <a:srgbClr val="2E3517"/>
-                </a:solidFill>
-                <a:latin typeface="Calibri"/>
-              </a:rPr>
-              <a:t>-</a:t>
-            </a:r>
-            <a:r>
-              <a:rPr sz="2400" b="0" dirty="0">
-                <a:solidFill>
-                  <a:srgbClr val="2E3517"/>
-                </a:solidFill>
-                <a:latin typeface="Calibri"/>
-              </a:rPr>
-              <a:t> volumes, EC, acid dosing.</a:t>
-            </a:r>
-          </a:p>
-          <a:p>
-            <a:pPr algn="l">
-              <a:lnSpc>
-                <a:spcPct val="106000"/>
-              </a:lnSpc>
-              <a:spcBef>
-                <a:spcPts val="0"/>
-              </a:spcBef>
-              <a:spcAft>
-                <a:spcPts val="400"/>
-              </a:spcAft>
-            </a:pPr>
-            <a:r>
-              <a:rPr sz="2400" b="1" dirty="0">
+              <a:rPr lang="he-IL" sz="2400" b="1" dirty="0">
                 <a:solidFill>
                   <a:srgbClr val="5E6E2E"/>
                 </a:solidFill>
-                <a:latin typeface="Calibri"/>
               </a:rPr>
-              <a:t>▪  </a:t>
+              <a:t>▪</a:t>
             </a:r>
             <a:r>
-              <a:rPr sz="2400" b="0" dirty="0">
+              <a:rPr lang="en-US" sz="2400" dirty="0">
                 <a:solidFill>
-                  <a:srgbClr val="2E3517"/>
+                  <a:schemeClr val="tx2">
+                    <a:lumMod val="75000"/>
+                  </a:schemeClr>
                 </a:solidFill>
-                <a:latin typeface="Calibri"/>
               </a:rPr>
-              <a:t>Crop-state / canopy features </a:t>
+              <a:t> Crop-state features — canopy cover, crop development and time-history variables.</a:t>
             </a:r>
+            <a:br>
+              <a:rPr lang="en-US" sz="2400" dirty="0">
+                <a:solidFill>
+                  <a:schemeClr val="tx2">
+                    <a:lumMod val="75000"/>
+                  </a:schemeClr>
+                </a:solidFill>
+              </a:rPr>
+            </a:br>
             <a:r>
-              <a:rPr lang="he-IL" sz="2400" b="0" dirty="0">
-                <a:solidFill>
-                  <a:srgbClr val="2E3517"/>
-                </a:solidFill>
-                <a:latin typeface="Calibri"/>
-              </a:rPr>
-              <a:t>-</a:t>
-            </a:r>
-            <a:r>
-              <a:rPr sz="2400" b="0" dirty="0">
-                <a:solidFill>
-                  <a:srgbClr val="2E3517"/>
-                </a:solidFill>
-                <a:latin typeface="Calibri"/>
-              </a:rPr>
-              <a:t> growth stage, canopy load.</a:t>
-            </a:r>
-          </a:p>
-          <a:p>
-            <a:pPr algn="l">
-              <a:lnSpc>
-                <a:spcPct val="106000"/>
-              </a:lnSpc>
-              <a:spcBef>
-                <a:spcPts val="0"/>
-              </a:spcBef>
-              <a:spcAft>
-                <a:spcPts val="400"/>
-              </a:spcAft>
-            </a:pPr>
-            <a:r>
-              <a:rPr sz="2400" b="1" dirty="0">
+              <a:rPr lang="he-IL" sz="2400" b="1" dirty="0">
                 <a:solidFill>
                   <a:srgbClr val="5E6E2E"/>
                 </a:solidFill>
-                <a:latin typeface="Calibri"/>
               </a:rPr>
-              <a:t>▪  </a:t>
+              <a:t>▪</a:t>
             </a:r>
             <a:r>
-              <a:rPr sz="2400" b="0" dirty="0">
+              <a:rPr lang="en-US" sz="2400" dirty="0">
                 <a:solidFill>
-                  <a:srgbClr val="2E3517"/>
+                  <a:schemeClr val="tx2">
+                    <a:lumMod val="75000"/>
+                  </a:schemeClr>
                 </a:solidFill>
-                <a:latin typeface="Calibri"/>
               </a:rPr>
-              <a:t>Manual laboratory pH &amp; EC </a:t>
+              <a:t> Manual laboratory pH &amp; EC measurements.</a:t>
             </a:r>
-            <a:r>
-              <a:rPr lang="he-IL" sz="2400" b="0" dirty="0">
-                <a:solidFill>
-                  <a:srgbClr val="2E3517"/>
-                </a:solidFill>
-                <a:latin typeface="Calibri"/>
-              </a:rPr>
-              <a:t>-</a:t>
-            </a:r>
-            <a:r>
-              <a:rPr sz="2400" b="0" dirty="0">
-                <a:solidFill>
-                  <a:srgbClr val="2E3517"/>
-                </a:solidFill>
-                <a:latin typeface="Calibri"/>
-              </a:rPr>
-              <a:t> sparse target labels.</a:t>
-            </a:r>
+            <a:endParaRPr sz="2400" b="0" dirty="0">
+              <a:solidFill>
+                <a:schemeClr val="tx2">
+                  <a:lumMod val="75000"/>
+                </a:schemeClr>
+              </a:solidFill>
+              <a:latin typeface="Calibri"/>
+            </a:endParaRPr>
           </a:p>
         </p:txBody>
       </p:sp>
@@ -13627,7 +13576,7 @@
                 <a:solidFill>
                   <a:srgbClr val="FFFFFF"/>
                 </a:solidFill>
-                <a:latin typeface="Calibri"/>
+                <a:latin typeface="+mj-lt"/>
               </a:rPr>
               <a:t>04</a:t>
             </a:r>
@@ -13672,7 +13621,7 @@
                 <a:solidFill>
                   <a:srgbClr val="3D4A1F"/>
                 </a:solidFill>
-                <a:latin typeface="Calibri"/>
+                <a:latin typeface="+mj-lt"/>
               </a:rPr>
               <a:t>Method</a:t>
             </a:r>
@@ -13934,7 +13883,7 @@
                 <a:solidFill>
                   <a:srgbClr val="FFFFFF"/>
                 </a:solidFill>
-                <a:latin typeface="Calibri"/>
+                <a:latin typeface="+mj-lt"/>
               </a:rPr>
               <a:t>05</a:t>
             </a:r>
@@ -13979,7 +13928,7 @@
                 <a:solidFill>
                   <a:srgbClr val="3D4A1F"/>
                 </a:solidFill>
-                <a:latin typeface="Calibri"/>
+                <a:latin typeface="+mj-lt"/>
               </a:rPr>
               <a:t>Algorithms &amp; Model Choice</a:t>
             </a:r>
@@ -14109,7 +14058,7 @@
               </a:spcAft>
             </a:pPr>
             <a:r>
-              <a:rPr sz="2400" b="0" dirty="0">
+              <a:rPr lang="en-US" sz="2400" b="0" dirty="0">
                 <a:solidFill>
                   <a:srgbClr val="2E3517"/>
                 </a:solidFill>
@@ -14198,7 +14147,7 @@
               </a:spcAft>
             </a:pPr>
             <a:r>
-              <a:rPr sz="2400" b="0" dirty="0">
+              <a:rPr lang="en-US" sz="2400" b="0" dirty="0">
                 <a:solidFill>
                   <a:srgbClr val="2E3517"/>
                 </a:solidFill>
@@ -14316,7 +14265,7 @@
                 <a:solidFill>
                   <a:srgbClr val="FFFFFF"/>
                 </a:solidFill>
-                <a:latin typeface="Calibri"/>
+                <a:latin typeface="+mj-lt"/>
               </a:rPr>
               <a:t>07</a:t>
             </a:r>
@@ -14324,7 +14273,7 @@
               <a:solidFill>
                 <a:srgbClr val="FFFFFF"/>
               </a:solidFill>
-              <a:latin typeface="Calibri"/>
+              <a:latin typeface="+mj-lt"/>
             </a:endParaRPr>
           </a:p>
         </p:txBody>
@@ -14367,34 +14316,10 @@
                 <a:solidFill>
                   <a:srgbClr val="3D4A1F"/>
                 </a:solidFill>
-                <a:latin typeface="Calibri"/>
+                <a:latin typeface="+mj-lt"/>
               </a:rPr>
               <a:t>Micro-Climate Model</a:t>
             </a:r>
-            <a:r>
-              <a:rPr lang="he-IL" sz="3600" b="1" i="0" dirty="0">
-                <a:solidFill>
-                  <a:srgbClr val="3D4A1F"/>
-                </a:solidFill>
-                <a:latin typeface="Calibri"/>
-              </a:rPr>
-              <a:t> </a:t>
-            </a:r>
-            <a:r>
-              <a:rPr lang="en-US" sz="3600" b="1" dirty="0">
-                <a:solidFill>
-                  <a:srgbClr val="3D4A1F"/>
-                </a:solidFill>
-                <a:latin typeface="Calibri"/>
-              </a:rPr>
-              <a:t>Results</a:t>
-            </a:r>
-            <a:endParaRPr sz="3600" b="1" i="0" dirty="0">
-              <a:solidFill>
-                <a:srgbClr val="3D4A1F"/>
-              </a:solidFill>
-              <a:latin typeface="Calibri"/>
-            </a:endParaRPr>
           </a:p>
         </p:txBody>
       </p:sp>
@@ -14465,83 +14390,43 @@
           </a:bodyPr>
           <a:lstStyle/>
           <a:p>
-            <a:pPr algn="l">
+            <a:pPr>
               <a:lnSpc>
                 <a:spcPct val="106000"/>
               </a:lnSpc>
-              <a:spcBef>
-                <a:spcPts val="0"/>
-              </a:spcBef>
               <a:spcAft>
                 <a:spcPts val="700"/>
               </a:spcAft>
             </a:pPr>
             <a:r>
-              <a:rPr sz="2400" b="1" i="0" dirty="0">
+              <a:rPr lang="en-US" sz="2400" dirty="0">
                 <a:solidFill>
-                  <a:srgbClr val="5E6E2E"/>
+                  <a:schemeClr val="tx2">
+                    <a:lumMod val="75000"/>
+                  </a:schemeClr>
                 </a:solidFill>
-                <a:latin typeface="Calibri"/>
               </a:rPr>
-              <a:t>▪  </a:t>
-            </a:r>
-            <a:r>
-              <a:rPr sz="2400" b="0" i="0" dirty="0">
-                <a:solidFill>
-                  <a:srgbClr val="2E3517"/>
-                </a:solidFill>
-                <a:latin typeface="Calibri"/>
-              </a:rPr>
-              <a:t>Estimates internal greenhouse climate from external weather &amp; radiation.</a:t>
+              <a:t>▪ Predicts internal greenhouse climate from external weather and radiation.</a:t>
             </a:r>
           </a:p>
           <a:p>
-            <a:pPr algn="l">
+            <a:pPr>
               <a:lnSpc>
                 <a:spcPct val="106000"/>
               </a:lnSpc>
-              <a:spcBef>
-                <a:spcPts val="0"/>
-              </a:spcBef>
               <a:spcAft>
                 <a:spcPts val="700"/>
               </a:spcAft>
             </a:pPr>
             <a:r>
-              <a:rPr sz="2400" b="1" i="0" dirty="0">
-                <a:solidFill>
-                  <a:srgbClr val="5E6E2E"/>
-                </a:solidFill>
-                <a:latin typeface="Calibri"/>
-              </a:rPr>
-              <a:t>▪  </a:t>
-            </a:r>
-            <a:r>
-              <a:rPr sz="2400" b="0" i="0" dirty="0">
-                <a:solidFill>
-                  <a:srgbClr val="2E3517"/>
-                </a:solidFill>
-                <a:latin typeface="Calibri"/>
-              </a:rPr>
-              <a:t>Feeds continuous climate features (ET₀, temperature, radiation</a:t>
-            </a:r>
-            <a:r>
               <a:rPr lang="en-US" sz="2400" dirty="0">
                 <a:solidFill>
-                  <a:srgbClr val="2E3517"/>
+                  <a:schemeClr val="tx2">
+                    <a:lumMod val="75000"/>
+                  </a:schemeClr>
                 </a:solidFill>
-                <a:latin typeface="Calibri"/>
               </a:rPr>
-              <a:t>, RH, soil temp</a:t>
-            </a:r>
-            <a:r>
-              <a:rPr sz="2400" b="0" i="0" dirty="0">
-                <a:solidFill>
-                  <a:srgbClr val="2E3517"/>
-                </a:solidFill>
-                <a:latin typeface="Calibri"/>
-              </a:rPr>
-              <a:t>) to the root-zone model.</a:t>
+              <a:t>▪ Generates continuous climate inputs - temperature, RH, radiation, ET₀ and soil temperature - for the root-zone model.</a:t>
             </a:r>
           </a:p>
         </p:txBody>
@@ -14562,8 +14447,8 @@
         </p:blipFill>
         <p:spPr>
           <a:xfrm>
-            <a:off x="14400000" y="13524100"/>
-            <a:ext cx="8640000" cy="5268672"/>
+            <a:off x="14016539" y="13542892"/>
+            <a:ext cx="8754968" cy="5338780"/>
           </a:xfrm>
           <a:prstGeom prst="rect">
             <a:avLst/>
@@ -14677,7 +14562,7 @@
                 <a:solidFill>
                   <a:srgbClr val="FFFFFF"/>
                 </a:solidFill>
-                <a:latin typeface="Calibri"/>
+                <a:latin typeface="+mj-lt"/>
               </a:rPr>
               <a:t>08</a:t>
             </a:r>
@@ -14711,6 +14596,7 @@
                 <a:solidFill>
                   <a:srgbClr val="3D4A1F"/>
                 </a:solidFill>
+                <a:latin typeface="+mj-lt"/>
               </a:rPr>
               <a:t>Root-zone Model Results</a:t>
             </a:r>
@@ -15439,7 +15325,7 @@
                 <a:solidFill>
                   <a:srgbClr val="FFFFFF"/>
                 </a:solidFill>
-                <a:latin typeface="Calibri"/>
+                <a:latin typeface="+mj-lt"/>
               </a:rPr>
               <a:t>09</a:t>
             </a:r>
@@ -15484,7 +15370,7 @@
                 <a:solidFill>
                   <a:srgbClr val="3D4A1F"/>
                 </a:solidFill>
-                <a:latin typeface="Calibri"/>
+                <a:latin typeface="+mj-lt"/>
               </a:rPr>
               <a:t>Conclusions</a:t>
             </a:r>
@@ -15795,7 +15681,7 @@
                 <a:solidFill>
                   <a:srgbClr val="FFFFFF"/>
                 </a:solidFill>
-                <a:latin typeface="Calibri"/>
+                <a:latin typeface="+mj-lt"/>
               </a:rPr>
               <a:t>10</a:t>
             </a:r>
@@ -15840,7 +15726,7 @@
                 <a:solidFill>
                   <a:srgbClr val="3D4A1F"/>
                 </a:solidFill>
-                <a:latin typeface="Calibri"/>
+                <a:latin typeface="+mj-lt"/>
               </a:rPr>
               <a:t>Challenges &amp; Limitations</a:t>
             </a:r>
@@ -16065,7 +15951,25 @@
                 </a:solidFill>
                 <a:latin typeface="Calibri"/>
               </a:rPr>
-              <a:t>Limited generalization — data from a single season and one crop.</a:t>
+              <a:t>Limited generalization </a:t>
+            </a:r>
+            <a:r>
+              <a:rPr lang="he-IL" sz="2400" b="0" dirty="0">
+                <a:solidFill>
+                  <a:srgbClr val="2E3517"/>
+                </a:solidFill>
+                <a:latin typeface="Calibri"/>
+              </a:rPr>
+              <a:t>-</a:t>
+            </a:r>
+            <a:r>
+              <a:rPr sz="2400" b="0" dirty="0">
+                <a:solidFill>
+                  <a:srgbClr val="2E3517"/>
+                </a:solidFill>
+                <a:latin typeface="Calibri"/>
+              </a:rPr>
+              <a:t> data from a single season and one crop.</a:t>
             </a:r>
           </a:p>
           <a:p>
@@ -16195,7 +16099,7 @@
         </p:blipFill>
         <p:spPr>
           <a:xfrm>
-            <a:off x="710412" y="19814396"/>
+            <a:off x="710412" y="19985846"/>
             <a:ext cx="11539173" cy="4461813"/>
           </a:xfrm>
           <a:prstGeom prst="rect">
@@ -16310,7 +16214,7 @@
                 <a:solidFill>
                   <a:srgbClr val="FFFFFF"/>
                 </a:solidFill>
-                <a:latin typeface="Calibri"/>
+                <a:latin typeface="+mj-lt"/>
               </a:rPr>
               <a:t>06</a:t>
             </a:r>
@@ -16318,7 +16222,7 @@
               <a:solidFill>
                 <a:srgbClr val="FFFFFF"/>
               </a:solidFill>
-              <a:latin typeface="Calibri"/>
+              <a:latin typeface="+mj-lt"/>
             </a:endParaRPr>
           </a:p>
         </p:txBody>
@@ -16357,11 +16261,11 @@
               </a:spcAft>
             </a:pPr>
             <a:r>
-              <a:rPr sz="3600" b="1" i="0">
+              <a:rPr sz="3600" b="1" i="0" dirty="0">
                 <a:solidFill>
                   <a:srgbClr val="3D4A1F"/>
                 </a:solidFill>
-                <a:latin typeface="Calibri"/>
+                <a:latin typeface="+mj-lt"/>
               </a:rPr>
               <a:t>Validation Strategy</a:t>
             </a:r>
@@ -16422,7 +16326,7 @@
         <p:spPr>
           <a:xfrm>
             <a:off x="13198650" y="4802325"/>
-            <a:ext cx="11052000" cy="1407812"/>
+            <a:ext cx="11052000" cy="1318044"/>
           </a:xfrm>
           <a:prstGeom prst="rect">
             <a:avLst/>
@@ -16451,7 +16355,6 @@
                 <a:solidFill>
                   <a:srgbClr val="5E6E2E"/>
                 </a:solidFill>
-                <a:latin typeface="Calibri"/>
               </a:rPr>
               <a:t>▪  </a:t>
             </a:r>
@@ -16460,87 +16363,111 @@
                 <a:solidFill>
                   <a:srgbClr val="2E3517"/>
                 </a:solidFill>
-                <a:latin typeface="Calibri"/>
               </a:rPr>
               <a:t>Walk-forward validation: train only on past observations, predict future samples.</a:t>
             </a:r>
           </a:p>
           <a:p>
-            <a:pPr algn="l">
+            <a:pPr>
               <a:lnSpc>
                 <a:spcPct val="106000"/>
               </a:lnSpc>
-              <a:spcBef>
-                <a:spcPts val="0"/>
-              </a:spcBef>
               <a:spcAft>
                 <a:spcPts val="700"/>
               </a:spcAft>
             </a:pPr>
             <a:r>
-              <a:rPr sz="2400" b="1" i="0" dirty="0">
+              <a:rPr lang="he-IL" sz="2400" b="1" dirty="0">
                 <a:solidFill>
                   <a:srgbClr val="5E6E2E"/>
                 </a:solidFill>
-                <a:latin typeface="Calibri"/>
               </a:rPr>
-              <a:t>▪  </a:t>
+              <a:t>▪</a:t>
+            </a:r>
+            <a:r>
+              <a:rPr sz="2400" b="1" i="0" dirty="0">
+                <a:solidFill>
+                  <a:schemeClr val="tx2">
+                    <a:lumMod val="75000"/>
+                  </a:schemeClr>
+                </a:solidFill>
+              </a:rPr>
+              <a:t> </a:t>
+            </a:r>
+            <a:r>
+              <a:rPr lang="en-US" sz="2400" b="1" i="0" dirty="0">
+                <a:solidFill>
+                  <a:schemeClr val="tx2">
+                    <a:lumMod val="75000"/>
+                  </a:schemeClr>
+                </a:solidFill>
+              </a:rPr>
+              <a:t> </a:t>
+            </a:r>
+            <a:r>
+              <a:rPr lang="en-US" sz="2400" dirty="0">
+                <a:solidFill>
+                  <a:schemeClr val="tx2">
+                    <a:lumMod val="75000"/>
+                  </a:schemeClr>
+                </a:solidFill>
+              </a:rPr>
+              <a:t>At each step, the next test interval becomes part of the following training period.</a:t>
+            </a:r>
+            <a:br>
+              <a:rPr lang="en-US" sz="2400" dirty="0">
+                <a:solidFill>
+                  <a:schemeClr val="tx2">
+                    <a:lumMod val="75000"/>
+                  </a:schemeClr>
+                </a:solidFill>
+              </a:rPr>
+            </a:br>
+            <a:r>
+              <a:rPr lang="he-IL" sz="2400" b="1" dirty="0">
+                <a:solidFill>
+                  <a:srgbClr val="5E6E2E"/>
+                </a:solidFill>
+              </a:rPr>
+              <a:t>▪</a:t>
+            </a:r>
+            <a:r>
+              <a:rPr sz="2400" b="1" i="0" dirty="0">
+                <a:solidFill>
+                  <a:schemeClr val="tx2">
+                    <a:lumMod val="75000"/>
+                  </a:schemeClr>
+                </a:solidFill>
+              </a:rPr>
+              <a:t>  </a:t>
             </a:r>
             <a:r>
               <a:rPr sz="2400" b="0" i="0" dirty="0">
                 <a:solidFill>
-                  <a:srgbClr val="2E3517"/>
+                  <a:schemeClr val="tx2">
+                    <a:lumMod val="75000"/>
+                  </a:schemeClr>
                 </a:solidFill>
-                <a:latin typeface="Calibri"/>
-              </a:rPr>
-              <a:t>Skipped-interval holdout: remove selected target intervals, predict them later.</a:t>
-            </a:r>
-          </a:p>
-          <a:p>
-            <a:pPr algn="l">
-              <a:lnSpc>
-                <a:spcPct val="106000"/>
-              </a:lnSpc>
-              <a:spcBef>
-                <a:spcPts val="0"/>
-              </a:spcBef>
-              <a:spcAft>
-                <a:spcPts val="700"/>
-              </a:spcAft>
-            </a:pPr>
-            <a:r>
-              <a:rPr sz="2400" b="1" i="0" dirty="0">
-                <a:solidFill>
-                  <a:srgbClr val="5E6E2E"/>
-                </a:solidFill>
-                <a:latin typeface="Calibri"/>
-              </a:rPr>
-              <a:t>▪  </a:t>
-            </a:r>
-            <a:r>
-              <a:rPr sz="2400" b="0" i="0" dirty="0">
-                <a:solidFill>
-                  <a:srgbClr val="2E3517"/>
-                </a:solidFill>
-                <a:latin typeface="Calibri"/>
               </a:rPr>
               <a:t>Metrics interpreted per target </a:t>
             </a:r>
             <a:r>
               <a:rPr lang="he-IL" sz="2400" b="0" i="0" dirty="0">
                 <a:solidFill>
-                  <a:srgbClr val="2E3517"/>
+                  <a:schemeClr val="tx2">
+                    <a:lumMod val="75000"/>
+                  </a:schemeClr>
                 </a:solidFill>
-                <a:latin typeface="Calibri"/>
               </a:rPr>
               <a:t>-</a:t>
             </a:r>
             <a:r>
               <a:rPr sz="2400" b="0" i="0" dirty="0">
                 <a:solidFill>
-                  <a:srgbClr val="2E3517"/>
+                  <a:schemeClr val="tx2">
+                    <a:lumMod val="75000"/>
+                  </a:schemeClr>
                 </a:solidFill>
-                <a:latin typeface="Calibri"/>
               </a:rPr>
               <a:t> pH (units) and EC (mS/cm).</a:t>
             </a:r>
@@ -16563,8 +16490,8 @@
         </p:blipFill>
         <p:spPr>
           <a:xfrm>
-            <a:off x="15196650" y="6548325"/>
-            <a:ext cx="7056000" cy="4302748"/>
+            <a:off x="14948999" y="6139419"/>
+            <a:ext cx="7757797" cy="4730704"/>
           </a:xfrm>
           <a:prstGeom prst="rect">
             <a:avLst/>

</xml_diff>

<commit_message>
Poster: add figure scripts and regenerate assets
Add scripts and generated assets for the Project 14 poster. New utilities: _figs_results.py (creates walk‑forward time series and holdout parity PNGs), _make_architecture.py (renders big-text architecture.png), _build_results.py (rebuilds card 08 in the PPTX to place new figures and text), _swap_arch.py (replaces the architecture image in the PPTX), and _dump.py (lists slide shapes). Also add generated images under poster/_figs and updated PPTX variants (add OLD copy, update V2 and main PPTX) while removing the PDF export. Scripts create backups before modifying the deliverable PPTX.
</commit_message>
<xml_diff>
--- a/poster/Predictive Modeling of Root-Zone Variables Using Greenhouse Data - Project 14.pptx
+++ b/poster/Predictive Modeling of Root-Zone Variables Using Greenhouse Data - Project 14.pptx
@@ -16077,36 +16077,6 @@
           </a:prstGeom>
         </p:spPr>
       </p:pic>
-      <p:pic>
-        <p:nvPicPr>
-          <p:cNvPr id="36" name="תמונה 35">
-            <a:extLst>
-              <a:ext uri="{FF2B5EF4-FFF2-40B4-BE49-F238E27FC236}">
-                <a16:creationId xmlns:a16="http://schemas.microsoft.com/office/drawing/2014/main" id="{18970B83-5CF0-EC42-97E5-46849577E6BE}"/>
-              </a:ext>
-            </a:extLst>
-          </p:cNvPr>
-          <p:cNvPicPr>
-            <a:picLocks noChangeAspect="1"/>
-          </p:cNvPicPr>
-          <p:nvPr/>
-        </p:nvPicPr>
-        <p:blipFill>
-          <a:blip r:embed="rId8"/>
-          <a:stretch>
-            <a:fillRect/>
-          </a:stretch>
-        </p:blipFill>
-        <p:spPr>
-          <a:xfrm>
-            <a:off x="710412" y="19985846"/>
-            <a:ext cx="11539173" cy="4461813"/>
-          </a:xfrm>
-          <a:prstGeom prst="rect">
-            <a:avLst/>
-          </a:prstGeom>
-        </p:spPr>
-      </p:pic>
       <p:sp>
         <p:nvSpPr>
           <p:cNvPr id="30" name="Rounded Rectangle 44"/>
@@ -16492,6 +16462,30 @@
           <a:xfrm>
             <a:off x="14948999" y="6139419"/>
             <a:ext cx="7757797" cy="4730704"/>
+          </a:xfrm>
+          <a:prstGeom prst="rect">
+            <a:avLst/>
+          </a:prstGeom>
+        </p:spPr>
+      </p:pic>
+      <p:pic>
+        <p:nvPicPr>
+          <p:cNvPr id="80" name="Picture 79" descr="architecture.png"/>
+          <p:cNvPicPr>
+            <a:picLocks noChangeAspect="1"/>
+          </p:cNvPicPr>
+          <p:nvPr/>
+        </p:nvPicPr>
+        <p:blipFill>
+          <a:blip r:embed="rId10"/>
+          <a:stretch>
+            <a:fillRect/>
+          </a:stretch>
+        </p:blipFill>
+        <p:spPr>
+          <a:xfrm>
+            <a:off x="710412" y="19985846"/>
+            <a:ext cx="11539173" cy="4460400"/>
           </a:xfrm>
           <a:prstGeom prst="rect">
             <a:avLst/>

</xml_diff>